<commit_message>
Fix Nova Sonic description - supports Chinese with ABC accent
Corrected the explanation for why we don't use Amazon Nova Sonic:

Previous (incorrect):
❌ Nova Sonic does not support Chinese

Updated (correct):
✅ Nova Sonic DOES support Chinese
⚠️  BUT has noticeable ABC accent (American-style Mandarin)
❌ Not suitable for Taiwan long-term care setting
   - Elderly and caregivers primarily use Taiwan Mandarin and Taiwanese

Updated files:
- docs/architecture.md
- docs/architecture-verification/ARCHITECTURE-COMPLETE.md
- docs/architecture-verification/Profit-Prophet-完整驗證.pptx (regenerated)

Presentation slide 6 now correctly explains:
- Nova Sonic supports Chinese but with ABC accent
- Not natural for Taiwan users
- Long-term care requires Taiwan Mandarin/Taiwanese

Thanks to user feedback for the correction!

Co-Authored-By: Claude Sonnet 4.5 <noreply@anthropic.com>
</commit_message>
<xml_diff>
--- a/docs/architecture-verification/Profit-Prophet-完整驗證.pptx
+++ b/docs/architecture-verification/Profit-Prophet-完整驗證.pptx
@@ -6929,8 +6929,8 @@
         </p:nvSpPr>
         <p:spPr>
           <a:xfrm>
-            <a:off x="1219169" y="4114800"/>
-            <a:ext cx="9753356" cy="411480"/>
+            <a:off x="1219169" y="4046220"/>
+            <a:ext cx="9753356" cy="342900"/>
           </a:xfrm>
           <a:prstGeom prst="rect">
             <a:avLst/>
@@ -6945,7 +6945,7 @@
           <a:p>
             <a:pPr algn="ctr"/>
             <a:r>
-              <a:rPr sz="2430" b="1" i="0">
+              <a:rPr sz="2160" b="1" i="0">
                 <a:solidFill>
                   <a:srgbClr val="DC2626">
                     <a:alpha val="100000"/>
@@ -6955,7 +6955,7 @@
                 <a:ea typeface="Arial"/>
                 <a:cs typeface="Arial"/>
               </a:rPr>
-              <a:t>❌ 但是...</a:t>
+              <a:t>⚠️ 但是...</a:t>
             </a:r>
           </a:p>
         </p:txBody>
@@ -6968,8 +6968,8 @@
         </p:nvSpPr>
         <p:spPr>
           <a:xfrm>
-            <a:off x="1828754" y="4663440"/>
-            <a:ext cx="8534186" cy="617220"/>
+            <a:off x="1828754" y="4526280"/>
+            <a:ext cx="8534186" cy="548640"/>
           </a:xfrm>
           <a:prstGeom prst="rect">
             <a:avLst/>
@@ -6994,7 +6994,7 @@
                 <a:ea typeface="Arial"/>
                 <a:cs typeface="Arial"/>
               </a:rPr>
-              <a:t>Nova Sonic 目前僅支援:</a:t>
+              <a:t>Nova Sonic 支援中文，但帶有明顯 ABC 腔調</a:t>
             </a:r>
           </a:p>
           <a:p>
@@ -7010,7 +7010,7 @@
                 <a:ea typeface="Arial"/>
                 <a:cs typeface="Arial"/>
               </a:rPr>
-              <a:t>英語、西班牙語、法語、義大利語、德語、葡萄牙語、印地語</a:t>
+              <a:t>(美式華語)</a:t>
             </a:r>
           </a:p>
         </p:txBody>
@@ -7023,8 +7023,8 @@
         </p:nvSpPr>
         <p:spPr>
           <a:xfrm>
-            <a:off x="1219169" y="5486400"/>
-            <a:ext cx="9753356" cy="480060"/>
+            <a:off x="1219169" y="5212080"/>
+            <a:ext cx="9753356" cy="411480"/>
           </a:xfrm>
           <a:prstGeom prst="rect">
             <a:avLst/>
@@ -7039,7 +7039,7 @@
           <a:p>
             <a:pPr algn="ctr"/>
             <a:r>
-              <a:rPr sz="2700" b="1" i="0">
+              <a:rPr sz="2052" b="1" i="0">
                 <a:solidFill>
                   <a:srgbClr val="DC2626">
                     <a:alpha val="100000"/>
@@ -7049,7 +7049,46 @@
                 <a:ea typeface="Arial"/>
                 <a:cs typeface="Arial"/>
               </a:rPr>
-              <a:t>❌ 不支援中文</a:t>
+              <a:t>❌ 不適合台灣長照現場</a:t>
+            </a:r>
+          </a:p>
+        </p:txBody>
+      </p:sp>
+      <p:sp>
+        <p:nvSpPr>
+          <p:cNvPr id="11" name="TextBox 10"/>
+          <p:cNvSpPr txBox="1"/>
+          <p:nvPr/>
+        </p:nvSpPr>
+        <p:spPr>
+          <a:xfrm>
+            <a:off x="1219169" y="5692140"/>
+            <a:ext cx="9753356" cy="274320"/>
+          </a:xfrm>
+          <a:prstGeom prst="rect">
+            <a:avLst/>
+          </a:prstGeom>
+          <a:noFill/>
+        </p:spPr>
+        <p:txBody>
+          <a:bodyPr wrap="square" anchor="ctr" lIns="0" rIns="0" tIns="0" bIns="0">
+            <a:spAutoFit/>
+          </a:bodyPr>
+          <a:lstStyle/>
+          <a:p>
+            <a:pPr algn="ctr"/>
+            <a:r>
+              <a:rPr sz="1404" b="0" i="0">
+                <a:solidFill>
+                  <a:srgbClr val="545B64">
+                    <a:alpha val="100000"/>
+                  </a:srgbClr>
+                </a:solidFill>
+                <a:latin typeface="Arial"/>
+                <a:ea typeface="Arial"/>
+                <a:cs typeface="Arial"/>
+              </a:rPr>
+              <a:t>長者與照服員主要使用台灣國語與台語</a:t>
             </a:r>
           </a:p>
         </p:txBody>

</xml_diff>